<commit_message>
Verify on real Kaggle data; fix ES NaN-company bug; update paper and slides with real results
- index_to_elasticsearch: postings with no company were sent as NaN (invalid
  JSON) and rejected; all 1500/1500 real postings now index
- Paper/slides: real-data accuracy (83.3%), XGBoost comparison, real feature
  weights and top skills; 30 tests
- Correct STRETCH_GOALS note that misattributed the 15 missing postings
- Verified end to end: Airflow DAG (real data, AUC 0.947), Kafka, Elasticsearch
</commit_message>
<xml_diff>
--- a/rsp/SkillBridge_Presentation.pptx
+++ b/rsp/SkillBridge_Presentation.pptx
@@ -118,33 +118,33 @@
   <p:extLst>
     <p:ext uri="{521415D9-36F7-43E2-AB2F-B90AF26B5E84}">
       <p14:sectionLst xmlns:p14="http://schemas.microsoft.com/office/powerpoint/2010/main">
-        <p14:section name="Introduction" id="{14cd6151-e7e4-436e-53d9-403c1a2e6382}">
+        <p14:section name="Introduction" id="{0d2fcedc-4bf7-1b6b-a2c2-42b0f711d7b9}">
           <p14:sldIdLst>
             <p14:sldId id="256"/>
             <p14:sldId id="257"/>
           </p14:sldIdLst>
         </p14:section>
-        <p14:section name="System" id="{97a3611a-d6ce-4e19-e707-86c74ce068f4}">
+        <p14:section name="System" id="{c432c0f1-185f-063f-a4ee-763fde623d18}">
           <p14:sldIdLst>
             <p14:sldId id="258"/>
             <p14:sldId id="259"/>
             <p14:sldId id="260"/>
           </p14:sldIdLst>
         </p14:section>
-        <p14:section name="Methods" id="{9b7fe9ff-e4f7-baec-e378-410c674fbd1a}">
+        <p14:section name="Methods" id="{2d26926e-9f75-d68f-16f7-7c66724863a5}">
           <p14:sldIdLst>
             <p14:sldId id="261"/>
             <p14:sldId id="262"/>
             <p14:sldId id="263"/>
           </p14:sldIdLst>
         </p14:section>
-        <p14:section name="Results" id="{6cac2cb0-8a14-5338-dedd-6a1c7fc01db3}">
+        <p14:section name="Results" id="{535500f9-5f0f-39f8-9614-3d725cc1bf8d}">
           <p14:sldIdLst>
             <p14:sldId id="264"/>
             <p14:sldId id="265"/>
           </p14:sldIdLst>
         </p14:section>
-        <p14:section name="Conclusion" id="{29634612-cf58-fbd3-d32f-9a63abdeb0ed}">
+        <p14:section name="Conclusion" id="{68567c00-6827-1c5f-5f43-3d01f2395157}">
           <p14:sldIdLst>
             <p14:sldId id="266"/>
             <p14:sldId id="267"/>
@@ -185,7 +185,7 @@
                 </a:solidFill>
                 <a:latin typeface="+mn-lt"/>
               </a:rPr>
-              <a:t>Top skills in postings (synthetic run)</a:t>
+              <a:t>Top skills in 1,500 real LinkedIn postings</a:t>
             </a:r>
           </a:p>
         </c:rich>
@@ -252,28 +252,28 @@
                 <c:ptCount val="8"/>
                 <c:lvl>
                   <c:pt idx="0">
-                    <c:v>ETL</c:v>
+                    <c:v>C</c:v>
                   </c:pt>
                   <c:pt idx="1">
-                    <c:v>Machine Learning</c:v>
+                    <c:v>SQL</c:v>
                   </c:pt>
                   <c:pt idx="2">
+                    <c:v>Teamwork</c:v>
+                  </c:pt>
+                  <c:pt idx="3">
+                    <c:v>Agile</c:v>
+                  </c:pt>
+                  <c:pt idx="4">
+                    <c:v>Problem Solving</c:v>
+                  </c:pt>
+                  <c:pt idx="5">
+                    <c:v>Time Management</c:v>
+                  </c:pt>
+                  <c:pt idx="6">
                     <c:v>Leadership</c:v>
                   </c:pt>
-                  <c:pt idx="3">
+                  <c:pt idx="7">
                     <c:v>Communication</c:v>
-                  </c:pt>
-                  <c:pt idx="4">
-                    <c:v>Teamwork</c:v>
-                  </c:pt>
-                  <c:pt idx="5">
-                    <c:v>Critical Thinking</c:v>
-                  </c:pt>
-                  <c:pt idx="6">
-                    <c:v>Time Management</c:v>
-                  </c:pt>
-                  <c:pt idx="7">
-                    <c:v>Problem Solving</c:v>
                   </c:pt>
                 </c:lvl>
               </c:multiLvlStrCache>
@@ -286,28 +286,28 @@
                 <c:formatCode>General</c:formatCode>
                 <c:ptCount val="8"/>
                 <c:pt idx="0">
-                  <c:v>11</c:v>
+                  <c:v>3.5</c:v>
                 </c:pt>
                 <c:pt idx="1">
-                  <c:v>11.7</c:v>
+                  <c:v>4.1</c:v>
                 </c:pt>
                 <c:pt idx="2">
-                  <c:v>18.3</c:v>
+                  <c:v>5</c:v>
                 </c:pt>
                 <c:pt idx="3">
-                  <c:v>21.7</c:v>
+                  <c:v>5.9</c:v>
                 </c:pt>
                 <c:pt idx="4">
-                  <c:v>21.7</c:v>
+                  <c:v>6.5</c:v>
                 </c:pt>
                 <c:pt idx="5">
-                  <c:v>22.3</c:v>
+                  <c:v>7.1</c:v>
                 </c:pt>
                 <c:pt idx="6">
-                  <c:v>24.7</c:v>
+                  <c:v>22.5</c:v>
                 </c:pt>
                 <c:pt idx="7">
-                  <c:v>27</c:v>
+                  <c:v>48.6</c:v>
                 </c:pt>
               </c:numCache>
             </c:numRef>
@@ -484,7 +484,7 @@
                 </a:solidFill>
                 <a:latin typeface="+mn-lt"/>
               </a:rPr>
-              <a:t>Synthetic data (noisy by design)</a:t>
+              <a:t>Real data: campus placement + LinkedIn</a:t>
             </a:r>
           </a:p>
         </c:rich>
@@ -567,10 +567,10 @@
                 <c:formatCode>General</c:formatCode>
                 <c:ptCount val="2"/>
                 <c:pt idx="0">
-                  <c:v>0.663</c:v>
+                  <c:v>0.947</c:v>
                 </c:pt>
                 <c:pt idx="1">
-                  <c:v>0.637</c:v>
+                  <c:v>0.896</c:v>
                 </c:pt>
               </c:numCache>
             </c:numRef>
@@ -644,10 +644,10 @@
                 <c:formatCode>General</c:formatCode>
                 <c:ptCount val="2"/>
                 <c:pt idx="0">
-                  <c:v>0.62</c:v>
+                  <c:v>0.833</c:v>
                 </c:pt>
                 <c:pt idx="1">
-                  <c:v>0.68</c:v>
+                  <c:v>0.778</c:v>
                 </c:pt>
               </c:numCache>
             </c:numRef>
@@ -3257,7 +3257,7 @@
                 <a:ea typeface="Cambria" pitchFamily="34" charset="-122"/>
                 <a:cs typeface="Cambria" pitchFamily="34" charset="-120"/>
               </a:rPr>
-              <a:t>1,485</a:t>
+              <a:t>1,500</a:t>
             </a:r>
             <a:endParaRPr lang="en-US" sz="3600" dirty="0"/>
           </a:p>
@@ -3354,7 +3354,7 @@
                 <a:ea typeface="Cambria" pitchFamily="34" charset="-122"/>
                 <a:cs typeface="Cambria" pitchFamily="34" charset="-120"/>
               </a:rPr>
-              <a:t>27</a:t>
+              <a:t>30</a:t>
             </a:r>
             <a:endParaRPr lang="en-US" sz="3600" dirty="0"/>
           </a:p>

</xml_diff>

<commit_message>
Pin scikit-learn/xgboost so Airflow-trained models load in the dashboard
- Airflow image had scikit-learn 1.9.1 vs 1.7.2 locally; the pickled model
  crashed the dashboard on predict. Versions now pinned identically in
  requirements.txt and infra/airflow/requirements-airflow.txt
- Dashboard smoke-tests the loaded model and shows a 'retrain' warning
  instead of crashing on any future mismatch
- pytest.ini: only collect tests/ (Airflow log symlinks broke collection)
- 31 tests; paper, slides and docs updated
</commit_message>
<xml_diff>
--- a/rsp/SkillBridge_Presentation.pptx
+++ b/rsp/SkillBridge_Presentation.pptx
@@ -118,33 +118,33 @@
   <p:extLst>
     <p:ext uri="{521415D9-36F7-43E2-AB2F-B90AF26B5E84}">
       <p14:sectionLst xmlns:p14="http://schemas.microsoft.com/office/powerpoint/2010/main">
-        <p14:section name="Introduction" id="{0d2fcedc-4bf7-1b6b-a2c2-42b0f711d7b9}">
+        <p14:section name="Introduction" id="{5d5c9c8c-2aa0-27a3-1a9d-442e562008c6}">
           <p14:sldIdLst>
             <p14:sldId id="256"/>
             <p14:sldId id="257"/>
           </p14:sldIdLst>
         </p14:section>
-        <p14:section name="System" id="{c432c0f1-185f-063f-a4ee-763fde623d18}">
+        <p14:section name="System" id="{fb57f852-6bfc-d82c-dd24-36a0af88e654}">
           <p14:sldIdLst>
             <p14:sldId id="258"/>
             <p14:sldId id="259"/>
             <p14:sldId id="260"/>
           </p14:sldIdLst>
         </p14:section>
-        <p14:section name="Methods" id="{2d26926e-9f75-d68f-16f7-7c66724863a5}">
+        <p14:section name="Methods" id="{bb4977bf-c9a4-4a38-4c58-3e139289f97b}">
           <p14:sldIdLst>
             <p14:sldId id="261"/>
             <p14:sldId id="262"/>
             <p14:sldId id="263"/>
           </p14:sldIdLst>
         </p14:section>
-        <p14:section name="Results" id="{535500f9-5f0f-39f8-9614-3d725cc1bf8d}">
+        <p14:section name="Results" id="{e577a5e4-0aac-1f8d-fe93-5082868e137d}">
           <p14:sldIdLst>
             <p14:sldId id="264"/>
             <p14:sldId id="265"/>
           </p14:sldIdLst>
         </p14:section>
-        <p14:section name="Conclusion" id="{68567c00-6827-1c5f-5f43-3d01f2395157}">
+        <p14:section name="Conclusion" id="{25ef2dd4-2216-c99b-de1d-ccd84f88ac15}">
           <p14:sldIdLst>
             <p14:sldId id="266"/>
             <p14:sldId id="267"/>
@@ -3354,7 +3354,7 @@
                 <a:ea typeface="Cambria" pitchFamily="34" charset="-122"/>
                 <a:cs typeface="Cambria" pitchFamily="34" charset="-120"/>
               </a:rPr>
-              <a:t>30</a:t>
+              <a:t>31</a:t>
             </a:r>
             <a:endParaRPr lang="en-US" sz="3600" dirty="0"/>
           </a:p>

</xml_diff>